<commit_message>
Add 3 reviewer-impact case-study visuals + deck/notebook integration
New script scripts/10_build_case_studies.py generates:
  - fig11_rank_redemption.png: cumulative top-K accuracy per substrate
    (overall: top-1=0.906 -> top-2=0.956 -> top-3=0.976 -> top-5=0.981)
  - fig12_confidence_vs_correct.png: 10-bin calibrated reliability
    (>=0.8 confidence is correct in 97.4% of cases, 676/694)
  - fig13_case_study_cards.png: 6 hand-picked PUL scenarios (confident
    correct, rank-2/3 redemptions, low-conf-correct, confident-wrong)
  - matching CSVs in docs/tables/

Decks: both static (pptx) and interactive (html) now have 24 slides
each, with 3 new slides for the wow visuals inserted after the
per-substrate sig-gene funnel.

Notebook: new Section H loads + displays the 3 case-study artifacts.

README: updated script count (10 drivers), deck slide count (24),
and added regeneration command for scripts/10.
</commit_message>
<xml_diff>
--- a/docs/deck.pptx
+++ b/docs/deck.pptx
@@ -26,6 +26,9 @@
     <p:sldId id="274" r:id="rId25"/>
     <p:sldId id="275" r:id="rId26"/>
     <p:sldId id="276" r:id="rId27"/>
+    <p:sldId id="277" r:id="rId28"/>
+    <p:sldId id="278" r:id="rId29"/>
+    <p:sldId id="279" r:id="rId30"/>
   </p:sldIdLst>
   <p:sldSz cx="12191695" cy="6858000" type="screen4x3"/>
   <p:notesSz cx="6858000" cy="9144000"/>
@@ -7181,6 +7184,561 @@
                   <a:srgbClr val="1A3A5C"/>
                 </a:solidFill>
               </a:rPr>
+              <a:t>Rank-K redemption — TRUE substrate is recovered fast as K grows</a:t>
+            </a:r>
+          </a:p>
+        </p:txBody>
+      </p:sp>
+      <p:sp>
+        <p:nvSpPr>
+          <p:cNvPr id="3" name="TextBox 2"/>
+          <p:cNvSpPr txBox="1"/>
+          <p:nvPr/>
+        </p:nvSpPr>
+        <p:spPr>
+          <a:xfrm>
+            <a:off x="548640" y="960120"/>
+            <a:ext cx="11094415" cy="365760"/>
+          </a:xfrm>
+          <a:prstGeom prst="rect">
+            <a:avLst/>
+          </a:prstGeom>
+          <a:noFill/>
+        </p:spPr>
+        <p:txBody>
+          <a:bodyPr wrap="square">
+            <a:spAutoFit/>
+          </a:bodyPr>
+          <a:lstStyle/>
+          <a:p>
+            <a:pPr algn="l"/>
+            <a:r>
+              <a:rPr sz="1400">
+                <a:solidFill>
+                  <a:srgbClr val="7F8C8D"/>
+                </a:solidFill>
+              </a:rPr>
+              <a:t>Cumulative top-K accuracy on 1030 held-out PULs (rep_1 OOF). When top-1 is wrong, the TRUE label is usually rank 2 or 3 — meaningful for triage workflows where biologists review the top few candidates.</a:t>
+            </a:r>
+          </a:p>
+        </p:txBody>
+      </p:sp>
+      <p:pic>
+        <p:nvPicPr>
+          <p:cNvPr id="4" name="Picture 3" descr="fig11_rank_redemption.png"/>
+          <p:cNvPicPr>
+            <a:picLocks noChangeAspect="1"/>
+          </p:cNvPicPr>
+          <p:nvPr/>
+        </p:nvPicPr>
+        <p:blipFill>
+          <a:blip r:embed="rId2"/>
+          <a:stretch>
+            <a:fillRect/>
+          </a:stretch>
+        </p:blipFill>
+        <p:spPr>
+          <a:xfrm>
+            <a:off x="2271992" y="1417320"/>
+            <a:ext cx="7647709" cy="4206240"/>
+          </a:xfrm>
+          <a:prstGeom prst="rect">
+            <a:avLst/>
+          </a:prstGeom>
+        </p:spPr>
+      </p:pic>
+      <p:sp>
+        <p:nvSpPr>
+          <p:cNvPr id="5" name="TextBox 4"/>
+          <p:cNvSpPr txBox="1"/>
+          <p:nvPr/>
+        </p:nvSpPr>
+        <p:spPr>
+          <a:xfrm>
+            <a:off x="365760" y="6126480"/>
+            <a:ext cx="11430000" cy="502920"/>
+          </a:xfrm>
+          <a:prstGeom prst="rect">
+            <a:avLst/>
+          </a:prstGeom>
+          <a:solidFill>
+            <a:srgbClr val="FFF9E6"/>
+          </a:solidFill>
+          <a:ln w="6350">
+            <a:solidFill>
+              <a:srgbClr val="2C3E50"/>
+            </a:solidFill>
+          </a:ln>
+        </p:spPr>
+        <p:txBody>
+          <a:bodyPr wrap="square">
+            <a:spAutoFit/>
+          </a:bodyPr>
+          <a:lstStyle/>
+          <a:p>
+            <a:pPr algn="l"/>
+            <a:r>
+              <a:rPr sz="1050" b="1">
+                <a:solidFill>
+                  <a:srgbClr val="2C3E50"/>
+                </a:solidFill>
+              </a:rPr>
+              <a:t>HEADLINE — top-1 = 0.906, top-2 = 0.956 (+5.0 pp), top-3 = 0.976 (+2.0 pp), top-5 = 0.981. Per-substrate: alginate is 100% at K=1; fructan is the hardest (top-1 = 0.677) but jumps to 0.903 by K=3 — i.e. when the model is wrong on fructan, the true class is almost always rank 2 or 3. Mean true-rank across all substrates = 1.39 (median 1). Calibrated probs make these ranks deployment-meaningful — see Slide 9.</a:t>
+            </a:r>
+          </a:p>
+        </p:txBody>
+      </p:sp>
+      <p:sp>
+        <p:nvSpPr>
+          <p:cNvPr id="6" name="TextBox 5"/>
+          <p:cNvSpPr txBox="1"/>
+          <p:nvPr/>
+        </p:nvSpPr>
+        <p:spPr>
+          <a:xfrm>
+            <a:off x="457200" y="6492240"/>
+            <a:ext cx="11277295" cy="274320"/>
+          </a:xfrm>
+          <a:prstGeom prst="rect">
+            <a:avLst/>
+          </a:prstGeom>
+          <a:noFill/>
+        </p:spPr>
+        <p:txBody>
+          <a:bodyPr wrap="none">
+            <a:spAutoFit/>
+          </a:bodyPr>
+          <a:lstStyle/>
+          <a:p>
+            <a:pPr algn="l"/>
+            <a:r>
+              <a:rPr sz="900" i="1">
+                <a:solidFill>
+                  <a:srgbClr val="7F8C8D"/>
+                </a:solidFill>
+              </a:rPr>
+              <a:t>subFinder substrate prediction — rep_1 reference run</a:t>
+            </a:r>
+          </a:p>
+        </p:txBody>
+      </p:sp>
+    </p:spTree>
+  </p:cSld>
+  <p:clrMapOvr>
+    <a:masterClrMapping/>
+  </p:clrMapOvr>
+</p:sld>
+</file>
+
+<file path=ppt/slides/slide15.xml><?xml version="1.0" encoding="utf-8"?>
+<p:sld xmlns:a="http://schemas.openxmlformats.org/drawingml/2006/main" xmlns:p="http://schemas.openxmlformats.org/presentationml/2006/main" xmlns:r="http://schemas.openxmlformats.org/officeDocument/2006/relationships">
+  <p:cSld>
+    <p:spTree>
+      <p:nvGrpSpPr>
+        <p:cNvPr id="1" name=""/>
+        <p:cNvGrpSpPr/>
+        <p:nvPr/>
+      </p:nvGrpSpPr>
+      <p:grpSpPr/>
+      <p:sp>
+        <p:nvSpPr>
+          <p:cNvPr id="2" name="TextBox 1"/>
+          <p:cNvSpPr txBox="1"/>
+          <p:nvPr/>
+        </p:nvSpPr>
+        <p:spPr>
+          <a:xfrm>
+            <a:off x="548640" y="320040"/>
+            <a:ext cx="11094415" cy="822960"/>
+          </a:xfrm>
+          <a:prstGeom prst="rect">
+            <a:avLst/>
+          </a:prstGeom>
+          <a:noFill/>
+        </p:spPr>
+        <p:txBody>
+          <a:bodyPr wrap="square">
+            <a:spAutoFit/>
+          </a:bodyPr>
+          <a:lstStyle/>
+          <a:p>
+            <a:pPr algn="l"/>
+            <a:r>
+              <a:rPr sz="2800" b="1">
+                <a:solidFill>
+                  <a:srgbClr val="1A3A5C"/>
+                </a:solidFill>
+              </a:rPr>
+              <a:t>Calibration is meaningful — confidence ≈ accuracy per bin</a:t>
+            </a:r>
+          </a:p>
+        </p:txBody>
+      </p:sp>
+      <p:sp>
+        <p:nvSpPr>
+          <p:cNvPr id="3" name="TextBox 2"/>
+          <p:cNvSpPr txBox="1"/>
+          <p:nvPr/>
+        </p:nvSpPr>
+        <p:spPr>
+          <a:xfrm>
+            <a:off x="548640" y="960120"/>
+            <a:ext cx="11094415" cy="365760"/>
+          </a:xfrm>
+          <a:prstGeom prst="rect">
+            <a:avLst/>
+          </a:prstGeom>
+          <a:noFill/>
+        </p:spPr>
+        <p:txBody>
+          <a:bodyPr wrap="square">
+            <a:spAutoFit/>
+          </a:bodyPr>
+          <a:lstStyle/>
+          <a:p>
+            <a:pPr algn="l"/>
+            <a:r>
+              <a:rPr sz="1400">
+                <a:solidFill>
+                  <a:srgbClr val="7F8C8D"/>
+                </a:solidFill>
+              </a:rPr>
+              <a:t>10-bin reliability histogram on calibrated probabilities (T ≈ 0.70). Sage = correct, red = incorrect. High-confidence predictions (≥0.8) ARE correct in ≥97% of cases — supports a triage/review workflow with a high-precision auto-accept threshold.</a:t>
+            </a:r>
+          </a:p>
+        </p:txBody>
+      </p:sp>
+      <p:pic>
+        <p:nvPicPr>
+          <p:cNvPr id="4" name="Picture 3" descr="fig12_confidence_vs_correct.png"/>
+          <p:cNvPicPr>
+            <a:picLocks noChangeAspect="1"/>
+          </p:cNvPicPr>
+          <p:nvPr/>
+        </p:nvPicPr>
+        <p:blipFill>
+          <a:blip r:embed="rId2"/>
+          <a:stretch>
+            <a:fillRect/>
+          </a:stretch>
+        </p:blipFill>
+        <p:spPr>
+          <a:xfrm>
+            <a:off x="2271992" y="1417320"/>
+            <a:ext cx="7647709" cy="4206240"/>
+          </a:xfrm>
+          <a:prstGeom prst="rect">
+            <a:avLst/>
+          </a:prstGeom>
+        </p:spPr>
+      </p:pic>
+      <p:sp>
+        <p:nvSpPr>
+          <p:cNvPr id="5" name="TextBox 4"/>
+          <p:cNvSpPr txBox="1"/>
+          <p:nvPr/>
+        </p:nvSpPr>
+        <p:spPr>
+          <a:xfrm>
+            <a:off x="365760" y="6126480"/>
+            <a:ext cx="11430000" cy="502920"/>
+          </a:xfrm>
+          <a:prstGeom prst="rect">
+            <a:avLst/>
+          </a:prstGeom>
+          <a:solidFill>
+            <a:srgbClr val="FFF9E6"/>
+          </a:solidFill>
+          <a:ln w="6350">
+            <a:solidFill>
+              <a:srgbClr val="2C3E50"/>
+            </a:solidFill>
+          </a:ln>
+        </p:spPr>
+        <p:txBody>
+          <a:bodyPr wrap="square">
+            <a:spAutoFit/>
+          </a:bodyPr>
+          <a:lstStyle/>
+          <a:p>
+            <a:pPr algn="l"/>
+            <a:r>
+              <a:rPr sz="1050" b="1">
+                <a:solidFill>
+                  <a:srgbClr val="2C3E50"/>
+                </a:solidFill>
+              </a:rPr>
+              <a:t>PER-BIN ACCURACY — 0.8-0.9 → 98.2% correct (110/112) · 0.9-1.0 → 97.3% correct (566/582). Combined ≥0.8: 97.4% correct on 694 PULs (67% of total). Bottom bins (≤0.5) show ~54-65% — the model 'knows it doesn't know'. Operational implication: route confidence ≥0.8 to auto-accept (precision ≈ 0.97), route 0.5-0.8 to expert review, refuse &lt;0.5. Same calibrator powers the deployed inference.</a:t>
+            </a:r>
+          </a:p>
+        </p:txBody>
+      </p:sp>
+      <p:sp>
+        <p:nvSpPr>
+          <p:cNvPr id="6" name="TextBox 5"/>
+          <p:cNvSpPr txBox="1"/>
+          <p:nvPr/>
+        </p:nvSpPr>
+        <p:spPr>
+          <a:xfrm>
+            <a:off x="457200" y="6492240"/>
+            <a:ext cx="11277295" cy="274320"/>
+          </a:xfrm>
+          <a:prstGeom prst="rect">
+            <a:avLst/>
+          </a:prstGeom>
+          <a:noFill/>
+        </p:spPr>
+        <p:txBody>
+          <a:bodyPr wrap="none">
+            <a:spAutoFit/>
+          </a:bodyPr>
+          <a:lstStyle/>
+          <a:p>
+            <a:pPr algn="l"/>
+            <a:r>
+              <a:rPr sz="900" i="1">
+                <a:solidFill>
+                  <a:srgbClr val="7F8C8D"/>
+                </a:solidFill>
+              </a:rPr>
+              <a:t>subFinder substrate prediction — rep_1 reference run</a:t>
+            </a:r>
+          </a:p>
+        </p:txBody>
+      </p:sp>
+    </p:spTree>
+  </p:cSld>
+  <p:clrMapOvr>
+    <a:masterClrMapping/>
+  </p:clrMapOvr>
+</p:sld>
+</file>
+
+<file path=ppt/slides/slide16.xml><?xml version="1.0" encoding="utf-8"?>
+<p:sld xmlns:a="http://schemas.openxmlformats.org/drawingml/2006/main" xmlns:p="http://schemas.openxmlformats.org/presentationml/2006/main" xmlns:r="http://schemas.openxmlformats.org/officeDocument/2006/relationships">
+  <p:cSld>
+    <p:spTree>
+      <p:nvGrpSpPr>
+        <p:cNvPr id="1" name=""/>
+        <p:cNvGrpSpPr/>
+        <p:nvPr/>
+      </p:nvGrpSpPr>
+      <p:grpSpPr/>
+      <p:sp>
+        <p:nvSpPr>
+          <p:cNvPr id="2" name="TextBox 1"/>
+          <p:cNvSpPr txBox="1"/>
+          <p:nvPr/>
+        </p:nvSpPr>
+        <p:spPr>
+          <a:xfrm>
+            <a:off x="548640" y="320040"/>
+            <a:ext cx="11094415" cy="822960"/>
+          </a:xfrm>
+          <a:prstGeom prst="rect">
+            <a:avLst/>
+          </a:prstGeom>
+          <a:noFill/>
+        </p:spPr>
+        <p:txBody>
+          <a:bodyPr wrap="square">
+            <a:spAutoFit/>
+          </a:bodyPr>
+          <a:lstStyle/>
+          <a:p>
+            <a:pPr algn="l"/>
+            <a:r>
+              <a:rPr sz="2800" b="1">
+                <a:solidFill>
+                  <a:srgbClr val="1A3A5C"/>
+                </a:solidFill>
+              </a:rPr>
+              <a:t>Case studies — 6 hand-picked PUL predictions showing the value of top-K + sig genes</a:t>
+            </a:r>
+          </a:p>
+        </p:txBody>
+      </p:sp>
+      <p:sp>
+        <p:nvSpPr>
+          <p:cNvPr id="3" name="TextBox 2"/>
+          <p:cNvSpPr txBox="1"/>
+          <p:nvPr/>
+        </p:nvSpPr>
+        <p:spPr>
+          <a:xfrm>
+            <a:off x="548640" y="960120"/>
+            <a:ext cx="11094415" cy="365760"/>
+          </a:xfrm>
+          <a:prstGeom prst="rect">
+            <a:avLst/>
+          </a:prstGeom>
+          <a:noFill/>
+        </p:spPr>
+        <p:txBody>
+          <a:bodyPr wrap="square">
+            <a:spAutoFit/>
+          </a:bodyPr>
+          <a:lstStyle/>
+          <a:p>
+            <a:pPr algn="l"/>
+            <a:r>
+              <a:rPr sz="1400">
+                <a:solidFill>
+                  <a:srgbClr val="7F8C8D"/>
+                </a:solidFill>
+              </a:rPr>
+              <a:t>Each card: TRUE substrate, model's top-3 (calibrated probs), and the gene sequence. Mix of confident-correct, low-conf-correct, rank-2/3 redemptions, and a confident-wrong failure mode.</a:t>
+            </a:r>
+          </a:p>
+        </p:txBody>
+      </p:sp>
+      <p:pic>
+        <p:nvPicPr>
+          <p:cNvPr id="4" name="Picture 3" descr="fig13_case_study_cards.png"/>
+          <p:cNvPicPr>
+            <a:picLocks noChangeAspect="1"/>
+          </p:cNvPicPr>
+          <p:nvPr/>
+        </p:nvPicPr>
+        <p:blipFill>
+          <a:blip r:embed="rId2"/>
+          <a:stretch>
+            <a:fillRect/>
+          </a:stretch>
+        </p:blipFill>
+        <p:spPr>
+          <a:xfrm>
+            <a:off x="3888976" y="1325880"/>
+            <a:ext cx="4413741" cy="4480560"/>
+          </a:xfrm>
+          <a:prstGeom prst="rect">
+            <a:avLst/>
+          </a:prstGeom>
+        </p:spPr>
+      </p:pic>
+      <p:sp>
+        <p:nvSpPr>
+          <p:cNvPr id="5" name="TextBox 4"/>
+          <p:cNvSpPr txBox="1"/>
+          <p:nvPr/>
+        </p:nvSpPr>
+        <p:spPr>
+          <a:xfrm>
+            <a:off x="365760" y="6126480"/>
+            <a:ext cx="11430000" cy="502920"/>
+          </a:xfrm>
+          <a:prstGeom prst="rect">
+            <a:avLst/>
+          </a:prstGeom>
+          <a:solidFill>
+            <a:srgbClr val="FFF9E6"/>
+          </a:solidFill>
+          <a:ln w="6350">
+            <a:solidFill>
+              <a:srgbClr val="2C3E50"/>
+            </a:solidFill>
+          </a:ln>
+        </p:spPr>
+        <p:txBody>
+          <a:bodyPr wrap="square">
+            <a:spAutoFit/>
+          </a:bodyPr>
+          <a:lstStyle/>
+          <a:p>
+            <a:pPr algn="l"/>
+            <a:r>
+              <a:rPr sz="1050" b="1">
+                <a:solidFill>
+                  <a:srgbClr val="2C3E50"/>
+                </a:solidFill>
+              </a:rPr>
+              <a:t>READING THE CARDS — green = top-1 is TRUE · amber = TRUE recovered at rank 2 or 3 · red = TRUE missing from top-3. Confident+correct (alginate, 0.96) shows clean signal: PL6/PL17 are canonical alginate lyases. Rank-2 redemption (alpha-glucan, 0.52 vs 0.32) — model splits between α/β-glucan, GH13 nudges α. Confident-wrong (alpha-glucan classified as fructan, p=1.0) — GH32/3.A.1.1.x are PRTS sucrose markers; ambiguous substrate.</a:t>
+            </a:r>
+          </a:p>
+        </p:txBody>
+      </p:sp>
+      <p:sp>
+        <p:nvSpPr>
+          <p:cNvPr id="6" name="TextBox 5"/>
+          <p:cNvSpPr txBox="1"/>
+          <p:nvPr/>
+        </p:nvSpPr>
+        <p:spPr>
+          <a:xfrm>
+            <a:off x="457200" y="6492240"/>
+            <a:ext cx="11277295" cy="274320"/>
+          </a:xfrm>
+          <a:prstGeom prst="rect">
+            <a:avLst/>
+          </a:prstGeom>
+          <a:noFill/>
+        </p:spPr>
+        <p:txBody>
+          <a:bodyPr wrap="none">
+            <a:spAutoFit/>
+          </a:bodyPr>
+          <a:lstStyle/>
+          <a:p>
+            <a:pPr algn="l"/>
+            <a:r>
+              <a:rPr sz="900" i="1">
+                <a:solidFill>
+                  <a:srgbClr val="7F8C8D"/>
+                </a:solidFill>
+              </a:rPr>
+              <a:t>subFinder substrate prediction — rep_1 reference run</a:t>
+            </a:r>
+          </a:p>
+        </p:txBody>
+      </p:sp>
+    </p:spTree>
+  </p:cSld>
+  <p:clrMapOvr>
+    <a:masterClrMapping/>
+  </p:clrMapOvr>
+</p:sld>
+</file>
+
+<file path=ppt/slides/slide17.xml><?xml version="1.0" encoding="utf-8"?>
+<p:sld xmlns:a="http://schemas.openxmlformats.org/drawingml/2006/main" xmlns:p="http://schemas.openxmlformats.org/presentationml/2006/main" xmlns:r="http://schemas.openxmlformats.org/officeDocument/2006/relationships">
+  <p:cSld>
+    <p:spTree>
+      <p:nvGrpSpPr>
+        <p:cNvPr id="1" name=""/>
+        <p:cNvGrpSpPr/>
+        <p:nvPr/>
+      </p:nvGrpSpPr>
+      <p:grpSpPr/>
+      <p:sp>
+        <p:nvSpPr>
+          <p:cNvPr id="2" name="TextBox 1"/>
+          <p:cNvSpPr txBox="1"/>
+          <p:nvPr/>
+        </p:nvSpPr>
+        <p:spPr>
+          <a:xfrm>
+            <a:off x="548640" y="320040"/>
+            <a:ext cx="11094415" cy="822960"/>
+          </a:xfrm>
+          <a:prstGeom prst="rect">
+            <a:avLst/>
+          </a:prstGeom>
+          <a:noFill/>
+        </p:spPr>
+        <p:txBody>
+          <a:bodyPr wrap="square">
+            <a:spAutoFit/>
+          </a:bodyPr>
+          <a:lstStyle/>
+          <a:p>
+            <a:pPr algn="l"/>
+            <a:r>
+              <a:rPr sz="2800" b="1">
+                <a:solidFill>
+                  <a:srgbClr val="1A3A5C"/>
+                </a:solidFill>
+              </a:rPr>
               <a:t>Internal robustness — accuracy vs train-vocab OOV proportion</a:t>
             </a:r>
           </a:p>
@@ -7327,7 +7885,7 @@
 </p:sld>
 </file>
 
-<file path=ppt/slides/slide15.xml><?xml version="1.0" encoding="utf-8"?>
+<file path=ppt/slides/slide18.xml><?xml version="1.0" encoding="utf-8"?>
 <p:sld xmlns:a="http://schemas.openxmlformats.org/drawingml/2006/main" xmlns:p="http://schemas.openxmlformats.org/presentationml/2006/main" xmlns:r="http://schemas.openxmlformats.org/officeDocument/2006/relationships">
   <p:cSld>
     <p:spTree>
@@ -7512,7 +8070,7 @@
 </p:sld>
 </file>
 
-<file path=ppt/slides/slide16.xml><?xml version="1.0" encoding="utf-8"?>
+<file path=ppt/slides/slide19.xml><?xml version="1.0" encoding="utf-8"?>
 <p:sld xmlns:a="http://schemas.openxmlformats.org/drawingml/2006/main" xmlns:p="http://schemas.openxmlformats.org/presentationml/2006/main" xmlns:r="http://schemas.openxmlformats.org/officeDocument/2006/relationships">
   <p:cSld>
     <p:spTree>
@@ -12133,7 +12691,7 @@
 </p:sld>
 </file>
 
-<file path=ppt/slides/slide17.xml><?xml version="1.0" encoding="utf-8"?>
+<file path=ppt/slides/slide2.xml><?xml version="1.0" encoding="utf-8"?>
 <p:sld xmlns:a="http://schemas.openxmlformats.org/drawingml/2006/main" xmlns:p="http://schemas.openxmlformats.org/presentationml/2006/main" xmlns:r="http://schemas.openxmlformats.org/officeDocument/2006/relationships">
   <p:cSld>
     <p:spTree>
@@ -12172,7 +12730,7 @@
                   <a:srgbClr val="1A3A5C"/>
                 </a:solidFill>
               </a:rPr>
-              <a:t>Appendix · Performance by featurizer family</a:t>
+              <a:t>Problem setup</a:t>
             </a:r>
           </a:p>
         </p:txBody>
@@ -12206,585 +12764,21 @@
                   <a:srgbClr val="7F8C8D"/>
                 </a:solidFill>
               </a:rPr>
-              <a:t>Averaged over all (config, seed, fold) trials sharing the same featurizer family</a:t>
+              <a:t>Predict one of 12 polysaccharide substrate classes from a PUL's gene-token sequence</a:t>
             </a:r>
           </a:p>
         </p:txBody>
       </p:sp>
-      <p:graphicFrame>
-        <p:nvGraphicFramePr>
-          <p:cNvPr id="4" name="Table 3"/>
-          <p:cNvGraphicFramePr>
-            <a:graphicFrameLocks noGrp="1"/>
-          </p:cNvGraphicFramePr>
-          <p:nvPr/>
-        </p:nvGraphicFramePr>
-        <p:xfrm>
-          <a:off x="1371600" y="1463040"/>
-          <a:ext cx="9418320" cy="3291840"/>
-        </p:xfrm>
-        <a:graphic>
-          <a:graphicData uri="http://schemas.openxmlformats.org/drawingml/2006/table">
-            <a:tbl>
-              <a:tblPr firstRow="1" bandRow="1">
-                <a:tableStyleId>{5C22544A-7EE6-4342-B048-85BDC9FD1C3A}</a:tableStyleId>
-              </a:tblPr>
-              <a:tblGrid>
-                <a:gridCol w="2560320"/>
-                <a:gridCol w="1828800"/>
-                <a:gridCol w="1371600"/>
-                <a:gridCol w="1645920"/>
-                <a:gridCol w="2011680"/>
-              </a:tblGrid>
-              <a:tr h="658368">
-                <a:tc>
-                  <a:txBody>
-                    <a:bodyPr/>
-                    <a:lstStyle/>
-                    <a:p>
-                      <a:r>
-                        <a:rPr b="1" sz="1200">
-                          <a:solidFill>
-                            <a:srgbClr val="FFFFFF"/>
-                          </a:solidFill>
-                        </a:rPr>
-                        <a:t>featurizer family</a:t>
-                      </a:r>
-                    </a:p>
-                  </a:txBody>
-                  <a:tcPr>
-                    <a:solidFill>
-                      <a:srgbClr val="1A3A5C"/>
-                    </a:solidFill>
-                  </a:tcPr>
-                </a:tc>
-                <a:tc>
-                  <a:txBody>
-                    <a:bodyPr/>
-                    <a:lstStyle/>
-                    <a:p>
-                      <a:r>
-                        <a:rPr b="1" sz="1200">
-                          <a:solidFill>
-                            <a:srgbClr val="FFFFFF"/>
-                          </a:solidFill>
-                        </a:rPr>
-                        <a:t>mean accuracy</a:t>
-                      </a:r>
-                    </a:p>
-                  </a:txBody>
-                  <a:tcPr>
-                    <a:solidFill>
-                      <a:srgbClr val="1A3A5C"/>
-                    </a:solidFill>
-                  </a:tcPr>
-                </a:tc>
-                <a:tc>
-                  <a:txBody>
-                    <a:bodyPr/>
-                    <a:lstStyle/>
-                    <a:p>
-                      <a:r>
-                        <a:rPr b="1" sz="1200">
-                          <a:solidFill>
-                            <a:srgbClr val="FFFFFF"/>
-                          </a:solidFill>
-                        </a:rPr>
-                        <a:t>std</a:t>
-                      </a:r>
-                    </a:p>
-                  </a:txBody>
-                  <a:tcPr>
-                    <a:solidFill>
-                      <a:srgbClr val="1A3A5C"/>
-                    </a:solidFill>
-                  </a:tcPr>
-                </a:tc>
-                <a:tc>
-                  <a:txBody>
-                    <a:bodyPr/>
-                    <a:lstStyle/>
-                    <a:p>
-                      <a:r>
-                        <a:rPr b="1" sz="1200">
-                          <a:solidFill>
-                            <a:srgbClr val="FFFFFF"/>
-                          </a:solidFill>
-                        </a:rPr>
-                        <a:t>n configs</a:t>
-                      </a:r>
-                    </a:p>
-                  </a:txBody>
-                  <a:tcPr>
-                    <a:solidFill>
-                      <a:srgbClr val="1A3A5C"/>
-                    </a:solidFill>
-                  </a:tcPr>
-                </a:tc>
-                <a:tc>
-                  <a:txBody>
-                    <a:bodyPr/>
-                    <a:lstStyle/>
-                    <a:p>
-                      <a:r>
-                        <a:rPr b="1" sz="1200">
-                          <a:solidFill>
-                            <a:srgbClr val="FFFFFF"/>
-                          </a:solidFill>
-                        </a:rPr>
-                        <a:t>n trials</a:t>
-                      </a:r>
-                    </a:p>
-                  </a:txBody>
-                  <a:tcPr>
-                    <a:solidFill>
-                      <a:srgbClr val="1A3A5C"/>
-                    </a:solidFill>
-                  </a:tcPr>
-                </a:tc>
-              </a:tr>
-              <a:tr h="658368">
-                <a:tc>
-                  <a:txBody>
-                    <a:bodyPr/>
-                    <a:lstStyle/>
-                    <a:p>
-                      <a:r>
-                        <a:rPr sz="1100">
-                          <a:solidFill>
-                            <a:srgbClr val="2C3E50"/>
-                          </a:solidFill>
-                        </a:rPr>
-                        <a:t>CountVec</a:t>
-                      </a:r>
-                    </a:p>
-                  </a:txBody>
-                  <a:tcPr>
-                    <a:solidFill>
-                      <a:srgbClr val="FFFFFF"/>
-                    </a:solidFill>
-                  </a:tcPr>
-                </a:tc>
-                <a:tc>
-                  <a:txBody>
-                    <a:bodyPr/>
-                    <a:lstStyle/>
-                    <a:p>
-                      <a:r>
-                        <a:rPr sz="1100">
-                          <a:solidFill>
-                            <a:srgbClr val="2C3E50"/>
-                          </a:solidFill>
-                        </a:rPr>
-                        <a:t>0.8734</a:t>
-                      </a:r>
-                    </a:p>
-                  </a:txBody>
-                  <a:tcPr>
-                    <a:solidFill>
-                      <a:srgbClr val="FFFFFF"/>
-                    </a:solidFill>
-                  </a:tcPr>
-                </a:tc>
-                <a:tc>
-                  <a:txBody>
-                    <a:bodyPr/>
-                    <a:lstStyle/>
-                    <a:p>
-                      <a:r>
-                        <a:rPr sz="1100">
-                          <a:solidFill>
-                            <a:srgbClr val="2C3E50"/>
-                          </a:solidFill>
-                        </a:rPr>
-                        <a:t>0.0399</a:t>
-                      </a:r>
-                    </a:p>
-                  </a:txBody>
-                  <a:tcPr>
-                    <a:solidFill>
-                      <a:srgbClr val="FFFFFF"/>
-                    </a:solidFill>
-                  </a:tcPr>
-                </a:tc>
-                <a:tc>
-                  <a:txBody>
-                    <a:bodyPr/>
-                    <a:lstStyle/>
-                    <a:p>
-                      <a:r>
-                        <a:rPr sz="1100">
-                          <a:solidFill>
-                            <a:srgbClr val="2C3E50"/>
-                          </a:solidFill>
-                        </a:rPr>
-                        <a:t>2</a:t>
-                      </a:r>
-                    </a:p>
-                  </a:txBody>
-                  <a:tcPr>
-                    <a:solidFill>
-                      <a:srgbClr val="FFFFFF"/>
-                    </a:solidFill>
-                  </a:tcPr>
-                </a:tc>
-                <a:tc>
-                  <a:txBody>
-                    <a:bodyPr/>
-                    <a:lstStyle/>
-                    <a:p>
-                      <a:r>
-                        <a:rPr sz="1100">
-                          <a:solidFill>
-                            <a:srgbClr val="2C3E50"/>
-                          </a:solidFill>
-                        </a:rPr>
-                        <a:t>50</a:t>
-                      </a:r>
-                    </a:p>
-                  </a:txBody>
-                  <a:tcPr>
-                    <a:solidFill>
-                      <a:srgbClr val="FFFFFF"/>
-                    </a:solidFill>
-                  </a:tcPr>
-                </a:tc>
-              </a:tr>
-              <a:tr h="658368">
-                <a:tc>
-                  <a:txBody>
-                    <a:bodyPr/>
-                    <a:lstStyle/>
-                    <a:p>
-                      <a:r>
-                        <a:rPr sz="1100">
-                          <a:solidFill>
-                            <a:srgbClr val="2C3E50"/>
-                          </a:solidFill>
-                        </a:rPr>
-                        <a:t>FastText</a:t>
-                      </a:r>
-                    </a:p>
-                  </a:txBody>
-                  <a:tcPr>
-                    <a:solidFill>
-                      <a:srgbClr val="ECF0F1"/>
-                    </a:solidFill>
-                  </a:tcPr>
-                </a:tc>
-                <a:tc>
-                  <a:txBody>
-                    <a:bodyPr/>
-                    <a:lstStyle/>
-                    <a:p>
-                      <a:r>
-                        <a:rPr sz="1100">
-                          <a:solidFill>
-                            <a:srgbClr val="2C3E50"/>
-                          </a:solidFill>
-                        </a:rPr>
-                        <a:t>0.7928</a:t>
-                      </a:r>
-                    </a:p>
-                  </a:txBody>
-                  <a:tcPr>
-                    <a:solidFill>
-                      <a:srgbClr val="ECF0F1"/>
-                    </a:solidFill>
-                  </a:tcPr>
-                </a:tc>
-                <a:tc>
-                  <a:txBody>
-                    <a:bodyPr/>
-                    <a:lstStyle/>
-                    <a:p>
-                      <a:r>
-                        <a:rPr sz="1100">
-                          <a:solidFill>
-                            <a:srgbClr val="2C3E50"/>
-                          </a:solidFill>
-                        </a:rPr>
-                        <a:t>0.0514</a:t>
-                      </a:r>
-                    </a:p>
-                  </a:txBody>
-                  <a:tcPr>
-                    <a:solidFill>
-                      <a:srgbClr val="ECF0F1"/>
-                    </a:solidFill>
-                  </a:tcPr>
-                </a:tc>
-                <a:tc>
-                  <a:txBody>
-                    <a:bodyPr/>
-                    <a:lstStyle/>
-                    <a:p>
-                      <a:r>
-                        <a:rPr sz="1100">
-                          <a:solidFill>
-                            <a:srgbClr val="2C3E50"/>
-                          </a:solidFill>
-                        </a:rPr>
-                        <a:t>11</a:t>
-                      </a:r>
-                    </a:p>
-                  </a:txBody>
-                  <a:tcPr>
-                    <a:solidFill>
-                      <a:srgbClr val="ECF0F1"/>
-                    </a:solidFill>
-                  </a:tcPr>
-                </a:tc>
-                <a:tc>
-                  <a:txBody>
-                    <a:bodyPr/>
-                    <a:lstStyle/>
-                    <a:p>
-                      <a:r>
-                        <a:rPr sz="1100">
-                          <a:solidFill>
-                            <a:srgbClr val="2C3E50"/>
-                          </a:solidFill>
-                        </a:rPr>
-                        <a:t>275</a:t>
-                      </a:r>
-                    </a:p>
-                  </a:txBody>
-                  <a:tcPr>
-                    <a:solidFill>
-                      <a:srgbClr val="ECF0F1"/>
-                    </a:solidFill>
-                  </a:tcPr>
-                </a:tc>
-              </a:tr>
-              <a:tr h="658368">
-                <a:tc>
-                  <a:txBody>
-                    <a:bodyPr/>
-                    <a:lstStyle/>
-                    <a:p>
-                      <a:r>
-                        <a:rPr sz="1100">
-                          <a:solidFill>
-                            <a:srgbClr val="2C3E50"/>
-                          </a:solidFill>
-                        </a:rPr>
-                        <a:t>Word2Vec</a:t>
-                      </a:r>
-                    </a:p>
-                  </a:txBody>
-                  <a:tcPr>
-                    <a:solidFill>
-                      <a:srgbClr val="FFFFFF"/>
-                    </a:solidFill>
-                  </a:tcPr>
-                </a:tc>
-                <a:tc>
-                  <a:txBody>
-                    <a:bodyPr/>
-                    <a:lstStyle/>
-                    <a:p>
-                      <a:r>
-                        <a:rPr sz="1100">
-                          <a:solidFill>
-                            <a:srgbClr val="2C3E50"/>
-                          </a:solidFill>
-                        </a:rPr>
-                        <a:t>0.7752</a:t>
-                      </a:r>
-                    </a:p>
-                  </a:txBody>
-                  <a:tcPr>
-                    <a:solidFill>
-                      <a:srgbClr val="FFFFFF"/>
-                    </a:solidFill>
-                  </a:tcPr>
-                </a:tc>
-                <a:tc>
-                  <a:txBody>
-                    <a:bodyPr/>
-                    <a:lstStyle/>
-                    <a:p>
-                      <a:r>
-                        <a:rPr sz="1100">
-                          <a:solidFill>
-                            <a:srgbClr val="2C3E50"/>
-                          </a:solidFill>
-                        </a:rPr>
-                        <a:t>0.0386</a:t>
-                      </a:r>
-                    </a:p>
-                  </a:txBody>
-                  <a:tcPr>
-                    <a:solidFill>
-                      <a:srgbClr val="FFFFFF"/>
-                    </a:solidFill>
-                  </a:tcPr>
-                </a:tc>
-                <a:tc>
-                  <a:txBody>
-                    <a:bodyPr/>
-                    <a:lstStyle/>
-                    <a:p>
-                      <a:r>
-                        <a:rPr sz="1100">
-                          <a:solidFill>
-                            <a:srgbClr val="2C3E50"/>
-                          </a:solidFill>
-                        </a:rPr>
-                        <a:t>10</a:t>
-                      </a:r>
-                    </a:p>
-                  </a:txBody>
-                  <a:tcPr>
-                    <a:solidFill>
-                      <a:srgbClr val="FFFFFF"/>
-                    </a:solidFill>
-                  </a:tcPr>
-                </a:tc>
-                <a:tc>
-                  <a:txBody>
-                    <a:bodyPr/>
-                    <a:lstStyle/>
-                    <a:p>
-                      <a:r>
-                        <a:rPr sz="1100">
-                          <a:solidFill>
-                            <a:srgbClr val="2C3E50"/>
-                          </a:solidFill>
-                        </a:rPr>
-                        <a:t>250</a:t>
-                      </a:r>
-                    </a:p>
-                  </a:txBody>
-                  <a:tcPr>
-                    <a:solidFill>
-                      <a:srgbClr val="FFFFFF"/>
-                    </a:solidFill>
-                  </a:tcPr>
-                </a:tc>
-              </a:tr>
-              <a:tr h="658368">
-                <a:tc>
-                  <a:txBody>
-                    <a:bodyPr/>
-                    <a:lstStyle/>
-                    <a:p>
-                      <a:r>
-                        <a:rPr sz="1100">
-                          <a:solidFill>
-                            <a:srgbClr val="2C3E50"/>
-                          </a:solidFill>
-                        </a:rPr>
-                        <a:t>Doc2Vec</a:t>
-                      </a:r>
-                    </a:p>
-                  </a:txBody>
-                  <a:tcPr>
-                    <a:solidFill>
-                      <a:srgbClr val="ECF0F1"/>
-                    </a:solidFill>
-                  </a:tcPr>
-                </a:tc>
-                <a:tc>
-                  <a:txBody>
-                    <a:bodyPr/>
-                    <a:lstStyle/>
-                    <a:p>
-                      <a:r>
-                        <a:rPr sz="1100">
-                          <a:solidFill>
-                            <a:srgbClr val="2C3E50"/>
-                          </a:solidFill>
-                        </a:rPr>
-                        <a:t>0.7508</a:t>
-                      </a:r>
-                    </a:p>
-                  </a:txBody>
-                  <a:tcPr>
-                    <a:solidFill>
-                      <a:srgbClr val="ECF0F1"/>
-                    </a:solidFill>
-                  </a:tcPr>
-                </a:tc>
-                <a:tc>
-                  <a:txBody>
-                    <a:bodyPr/>
-                    <a:lstStyle/>
-                    <a:p>
-                      <a:r>
-                        <a:rPr sz="1100">
-                          <a:solidFill>
-                            <a:srgbClr val="2C3E50"/>
-                          </a:solidFill>
-                        </a:rPr>
-                        <a:t>0.0394</a:t>
-                      </a:r>
-                    </a:p>
-                  </a:txBody>
-                  <a:tcPr>
-                    <a:solidFill>
-                      <a:srgbClr val="ECF0F1"/>
-                    </a:solidFill>
-                  </a:tcPr>
-                </a:tc>
-                <a:tc>
-                  <a:txBody>
-                    <a:bodyPr/>
-                    <a:lstStyle/>
-                    <a:p>
-                      <a:r>
-                        <a:rPr sz="1100">
-                          <a:solidFill>
-                            <a:srgbClr val="2C3E50"/>
-                          </a:solidFill>
-                        </a:rPr>
-                        <a:t>6</a:t>
-                      </a:r>
-                    </a:p>
-                  </a:txBody>
-                  <a:tcPr>
-                    <a:solidFill>
-                      <a:srgbClr val="ECF0F1"/>
-                    </a:solidFill>
-                  </a:tcPr>
-                </a:tc>
-                <a:tc>
-                  <a:txBody>
-                    <a:bodyPr/>
-                    <a:lstStyle/>
-                    <a:p>
-                      <a:r>
-                        <a:rPr sz="1100">
-                          <a:solidFill>
-                            <a:srgbClr val="2C3E50"/>
-                          </a:solidFill>
-                        </a:rPr>
-                        <a:t>150</a:t>
-                      </a:r>
-                    </a:p>
-                  </a:txBody>
-                  <a:tcPr>
-                    <a:solidFill>
-                      <a:srgbClr val="ECF0F1"/>
-                    </a:solidFill>
-                  </a:tcPr>
-                </a:tc>
-              </a:tr>
-            </a:tbl>
-          </a:graphicData>
-        </a:graphic>
-      </p:graphicFrame>
       <p:sp>
         <p:nvSpPr>
-          <p:cNvPr id="5" name="TextBox 4"/>
+          <p:cNvPr id="4" name="TextBox 3"/>
           <p:cNvSpPr txBox="1"/>
           <p:nvPr/>
         </p:nvSpPr>
         <p:spPr>
           <a:xfrm>
-            <a:off x="1371600" y="5029200"/>
-            <a:ext cx="9418320" cy="914400"/>
+            <a:off x="548640" y="1645920"/>
+            <a:ext cx="10515600" cy="4572000"/>
           </a:xfrm>
           <a:prstGeom prst="rect">
             <a:avLst/>
@@ -12797,20 +12791,102 @@
           </a:bodyPr>
           <a:lstStyle/>
           <a:p>
+            <a:pPr algn="l">
+              <a:spcAft>
+                <a:spcPts val="1400"/>
+              </a:spcAft>
+            </a:pPr>
             <a:r>
-              <a:rPr sz="1100" i="1">
+              <a:rPr sz="1500" b="1">
+                <a:solidFill>
+                  <a:srgbClr val="1A3A5C"/>
+                </a:solidFill>
+              </a:rPr>
+              <a:t>Dataset — </a:t>
+            </a:r>
+            <a:r>
+              <a:rPr sz="1500">
                 <a:solidFill>
                   <a:srgbClr val="2C3E50"/>
                 </a:solidFill>
               </a:rPr>
-              <a:t>Note: averages mix in different classifier choices. Pattern — CountVec leads because it carries our ExtraTrees winner; FastText/Word2Vec/Doc2Vec families are pulled down by their BRF/DL classifier pairings.</a:t>
+              <a:t>1,030 labeled PULs across 12 substrates (alginate, alpha-glucan, alpha-mannan, arabinogalactan, beta-glucan, beta-mannan, chitin, fructan, galactan, host glycan, pectin, xylan)</a:t>
+            </a:r>
+          </a:p>
+          <a:p>
+            <a:pPr algn="l">
+              <a:spcAft>
+                <a:spcPts val="1400"/>
+              </a:spcAft>
+            </a:pPr>
+            <a:r>
+              <a:rPr sz="1500" b="1">
+                <a:solidFill>
+                  <a:srgbClr val="1A3A5C"/>
+                </a:solidFill>
+              </a:rPr>
+              <a:t>Each PUL — </a:t>
+            </a:r>
+            <a:r>
+              <a:rPr sz="1500">
+                <a:solidFill>
+                  <a:srgbClr val="2C3E50"/>
+                </a:solidFill>
+              </a:rPr>
+              <a:t>a comma/pipe-separated string of CAZy family IDs, transporter classification IDs, transcription-factor types, and null padding</a:t>
+            </a:r>
+          </a:p>
+          <a:p>
+            <a:pPr algn="l">
+              <a:spcAft>
+                <a:spcPts val="1400"/>
+              </a:spcAft>
+            </a:pPr>
+            <a:r>
+              <a:rPr sz="1500" b="1">
+                <a:solidFill>
+                  <a:srgbClr val="1A3A5C"/>
+                </a:solidFill>
+              </a:rPr>
+              <a:t>Cross-validation — </a:t>
+            </a:r>
+            <a:r>
+              <a:rPr sz="1500">
+                <a:solidFill>
+                  <a:srgbClr val="2C3E50"/>
+                </a:solidFill>
+              </a:rPr>
+              <a:t>5-repeat × 5-fold Repeated Stratified K-Fold (n=25 trials per configuration) — leak-free: word-embedding models retrained per fold</a:t>
+            </a:r>
+          </a:p>
+          <a:p>
+            <a:pPr algn="l">
+              <a:spcAft>
+                <a:spcPts val="1400"/>
+              </a:spcAft>
+            </a:pPr>
+            <a:r>
+              <a:rPr sz="1500" b="1">
+                <a:solidFill>
+                  <a:srgbClr val="1A3A5C"/>
+                </a:solidFill>
+              </a:rPr>
+              <a:t>Goal — </a:t>
+            </a:r>
+            <a:r>
+              <a:rPr sz="1500">
+                <a:solidFill>
+                  <a:srgbClr val="2C3E50"/>
+                </a:solidFill>
+              </a:rPr>
+              <a:t>(1) maximise predictive accuracy, (2) emit calibrated probabilities, (3) produce per-PUL signature-gene attributions that match literature CAZy knowledge</a:t>
             </a:r>
           </a:p>
         </p:txBody>
       </p:sp>
       <p:sp>
         <p:nvSpPr>
-          <p:cNvPr id="6" name="TextBox 5"/>
+          <p:cNvPr id="5" name="TextBox 4"/>
           <p:cNvSpPr txBox="1"/>
           <p:nvPr/>
         </p:nvSpPr>
@@ -12850,7 +12926,7 @@
 </p:sld>
 </file>
 
-<file path=ppt/slides/slide18.xml><?xml version="1.0" encoding="utf-8"?>
+<file path=ppt/slides/slide20.xml><?xml version="1.0" encoding="utf-8"?>
 <p:sld xmlns:a="http://schemas.openxmlformats.org/drawingml/2006/main" xmlns:p="http://schemas.openxmlformats.org/presentationml/2006/main" xmlns:r="http://schemas.openxmlformats.org/officeDocument/2006/relationships">
   <p:cSld>
     <p:spTree>
@@ -12889,6 +12965,723 @@
                   <a:srgbClr val="1A3A5C"/>
                 </a:solidFill>
               </a:rPr>
+              <a:t>Appendix · Performance by featurizer family</a:t>
+            </a:r>
+          </a:p>
+        </p:txBody>
+      </p:sp>
+      <p:sp>
+        <p:nvSpPr>
+          <p:cNvPr id="3" name="TextBox 2"/>
+          <p:cNvSpPr txBox="1"/>
+          <p:nvPr/>
+        </p:nvSpPr>
+        <p:spPr>
+          <a:xfrm>
+            <a:off x="548640" y="960120"/>
+            <a:ext cx="11094415" cy="365760"/>
+          </a:xfrm>
+          <a:prstGeom prst="rect">
+            <a:avLst/>
+          </a:prstGeom>
+          <a:noFill/>
+        </p:spPr>
+        <p:txBody>
+          <a:bodyPr wrap="square">
+            <a:spAutoFit/>
+          </a:bodyPr>
+          <a:lstStyle/>
+          <a:p>
+            <a:pPr algn="l"/>
+            <a:r>
+              <a:rPr sz="1400">
+                <a:solidFill>
+                  <a:srgbClr val="7F8C8D"/>
+                </a:solidFill>
+              </a:rPr>
+              <a:t>Averaged over all (config, seed, fold) trials sharing the same featurizer family</a:t>
+            </a:r>
+          </a:p>
+        </p:txBody>
+      </p:sp>
+      <p:graphicFrame>
+        <p:nvGraphicFramePr>
+          <p:cNvPr id="4" name="Table 3"/>
+          <p:cNvGraphicFramePr>
+            <a:graphicFrameLocks noGrp="1"/>
+          </p:cNvGraphicFramePr>
+          <p:nvPr/>
+        </p:nvGraphicFramePr>
+        <p:xfrm>
+          <a:off x="1371600" y="1463040"/>
+          <a:ext cx="9418320" cy="3291840"/>
+        </p:xfrm>
+        <a:graphic>
+          <a:graphicData uri="http://schemas.openxmlformats.org/drawingml/2006/table">
+            <a:tbl>
+              <a:tblPr firstRow="1" bandRow="1">
+                <a:tableStyleId>{5C22544A-7EE6-4342-B048-85BDC9FD1C3A}</a:tableStyleId>
+              </a:tblPr>
+              <a:tblGrid>
+                <a:gridCol w="2560320"/>
+                <a:gridCol w="1828800"/>
+                <a:gridCol w="1371600"/>
+                <a:gridCol w="1645920"/>
+                <a:gridCol w="2011680"/>
+              </a:tblGrid>
+              <a:tr h="658368">
+                <a:tc>
+                  <a:txBody>
+                    <a:bodyPr/>
+                    <a:lstStyle/>
+                    <a:p>
+                      <a:r>
+                        <a:rPr b="1" sz="1200">
+                          <a:solidFill>
+                            <a:srgbClr val="FFFFFF"/>
+                          </a:solidFill>
+                        </a:rPr>
+                        <a:t>featurizer family</a:t>
+                      </a:r>
+                    </a:p>
+                  </a:txBody>
+                  <a:tcPr>
+                    <a:solidFill>
+                      <a:srgbClr val="1A3A5C"/>
+                    </a:solidFill>
+                  </a:tcPr>
+                </a:tc>
+                <a:tc>
+                  <a:txBody>
+                    <a:bodyPr/>
+                    <a:lstStyle/>
+                    <a:p>
+                      <a:r>
+                        <a:rPr b="1" sz="1200">
+                          <a:solidFill>
+                            <a:srgbClr val="FFFFFF"/>
+                          </a:solidFill>
+                        </a:rPr>
+                        <a:t>mean accuracy</a:t>
+                      </a:r>
+                    </a:p>
+                  </a:txBody>
+                  <a:tcPr>
+                    <a:solidFill>
+                      <a:srgbClr val="1A3A5C"/>
+                    </a:solidFill>
+                  </a:tcPr>
+                </a:tc>
+                <a:tc>
+                  <a:txBody>
+                    <a:bodyPr/>
+                    <a:lstStyle/>
+                    <a:p>
+                      <a:r>
+                        <a:rPr b="1" sz="1200">
+                          <a:solidFill>
+                            <a:srgbClr val="FFFFFF"/>
+                          </a:solidFill>
+                        </a:rPr>
+                        <a:t>std</a:t>
+                      </a:r>
+                    </a:p>
+                  </a:txBody>
+                  <a:tcPr>
+                    <a:solidFill>
+                      <a:srgbClr val="1A3A5C"/>
+                    </a:solidFill>
+                  </a:tcPr>
+                </a:tc>
+                <a:tc>
+                  <a:txBody>
+                    <a:bodyPr/>
+                    <a:lstStyle/>
+                    <a:p>
+                      <a:r>
+                        <a:rPr b="1" sz="1200">
+                          <a:solidFill>
+                            <a:srgbClr val="FFFFFF"/>
+                          </a:solidFill>
+                        </a:rPr>
+                        <a:t>n configs</a:t>
+                      </a:r>
+                    </a:p>
+                  </a:txBody>
+                  <a:tcPr>
+                    <a:solidFill>
+                      <a:srgbClr val="1A3A5C"/>
+                    </a:solidFill>
+                  </a:tcPr>
+                </a:tc>
+                <a:tc>
+                  <a:txBody>
+                    <a:bodyPr/>
+                    <a:lstStyle/>
+                    <a:p>
+                      <a:r>
+                        <a:rPr b="1" sz="1200">
+                          <a:solidFill>
+                            <a:srgbClr val="FFFFFF"/>
+                          </a:solidFill>
+                        </a:rPr>
+                        <a:t>n trials</a:t>
+                      </a:r>
+                    </a:p>
+                  </a:txBody>
+                  <a:tcPr>
+                    <a:solidFill>
+                      <a:srgbClr val="1A3A5C"/>
+                    </a:solidFill>
+                  </a:tcPr>
+                </a:tc>
+              </a:tr>
+              <a:tr h="658368">
+                <a:tc>
+                  <a:txBody>
+                    <a:bodyPr/>
+                    <a:lstStyle/>
+                    <a:p>
+                      <a:r>
+                        <a:rPr sz="1100">
+                          <a:solidFill>
+                            <a:srgbClr val="2C3E50"/>
+                          </a:solidFill>
+                        </a:rPr>
+                        <a:t>CountVec</a:t>
+                      </a:r>
+                    </a:p>
+                  </a:txBody>
+                  <a:tcPr>
+                    <a:solidFill>
+                      <a:srgbClr val="FFFFFF"/>
+                    </a:solidFill>
+                  </a:tcPr>
+                </a:tc>
+                <a:tc>
+                  <a:txBody>
+                    <a:bodyPr/>
+                    <a:lstStyle/>
+                    <a:p>
+                      <a:r>
+                        <a:rPr sz="1100">
+                          <a:solidFill>
+                            <a:srgbClr val="2C3E50"/>
+                          </a:solidFill>
+                        </a:rPr>
+                        <a:t>0.8734</a:t>
+                      </a:r>
+                    </a:p>
+                  </a:txBody>
+                  <a:tcPr>
+                    <a:solidFill>
+                      <a:srgbClr val="FFFFFF"/>
+                    </a:solidFill>
+                  </a:tcPr>
+                </a:tc>
+                <a:tc>
+                  <a:txBody>
+                    <a:bodyPr/>
+                    <a:lstStyle/>
+                    <a:p>
+                      <a:r>
+                        <a:rPr sz="1100">
+                          <a:solidFill>
+                            <a:srgbClr val="2C3E50"/>
+                          </a:solidFill>
+                        </a:rPr>
+                        <a:t>0.0399</a:t>
+                      </a:r>
+                    </a:p>
+                  </a:txBody>
+                  <a:tcPr>
+                    <a:solidFill>
+                      <a:srgbClr val="FFFFFF"/>
+                    </a:solidFill>
+                  </a:tcPr>
+                </a:tc>
+                <a:tc>
+                  <a:txBody>
+                    <a:bodyPr/>
+                    <a:lstStyle/>
+                    <a:p>
+                      <a:r>
+                        <a:rPr sz="1100">
+                          <a:solidFill>
+                            <a:srgbClr val="2C3E50"/>
+                          </a:solidFill>
+                        </a:rPr>
+                        <a:t>2</a:t>
+                      </a:r>
+                    </a:p>
+                  </a:txBody>
+                  <a:tcPr>
+                    <a:solidFill>
+                      <a:srgbClr val="FFFFFF"/>
+                    </a:solidFill>
+                  </a:tcPr>
+                </a:tc>
+                <a:tc>
+                  <a:txBody>
+                    <a:bodyPr/>
+                    <a:lstStyle/>
+                    <a:p>
+                      <a:r>
+                        <a:rPr sz="1100">
+                          <a:solidFill>
+                            <a:srgbClr val="2C3E50"/>
+                          </a:solidFill>
+                        </a:rPr>
+                        <a:t>50</a:t>
+                      </a:r>
+                    </a:p>
+                  </a:txBody>
+                  <a:tcPr>
+                    <a:solidFill>
+                      <a:srgbClr val="FFFFFF"/>
+                    </a:solidFill>
+                  </a:tcPr>
+                </a:tc>
+              </a:tr>
+              <a:tr h="658368">
+                <a:tc>
+                  <a:txBody>
+                    <a:bodyPr/>
+                    <a:lstStyle/>
+                    <a:p>
+                      <a:r>
+                        <a:rPr sz="1100">
+                          <a:solidFill>
+                            <a:srgbClr val="2C3E50"/>
+                          </a:solidFill>
+                        </a:rPr>
+                        <a:t>FastText</a:t>
+                      </a:r>
+                    </a:p>
+                  </a:txBody>
+                  <a:tcPr>
+                    <a:solidFill>
+                      <a:srgbClr val="ECF0F1"/>
+                    </a:solidFill>
+                  </a:tcPr>
+                </a:tc>
+                <a:tc>
+                  <a:txBody>
+                    <a:bodyPr/>
+                    <a:lstStyle/>
+                    <a:p>
+                      <a:r>
+                        <a:rPr sz="1100">
+                          <a:solidFill>
+                            <a:srgbClr val="2C3E50"/>
+                          </a:solidFill>
+                        </a:rPr>
+                        <a:t>0.7928</a:t>
+                      </a:r>
+                    </a:p>
+                  </a:txBody>
+                  <a:tcPr>
+                    <a:solidFill>
+                      <a:srgbClr val="ECF0F1"/>
+                    </a:solidFill>
+                  </a:tcPr>
+                </a:tc>
+                <a:tc>
+                  <a:txBody>
+                    <a:bodyPr/>
+                    <a:lstStyle/>
+                    <a:p>
+                      <a:r>
+                        <a:rPr sz="1100">
+                          <a:solidFill>
+                            <a:srgbClr val="2C3E50"/>
+                          </a:solidFill>
+                        </a:rPr>
+                        <a:t>0.0514</a:t>
+                      </a:r>
+                    </a:p>
+                  </a:txBody>
+                  <a:tcPr>
+                    <a:solidFill>
+                      <a:srgbClr val="ECF0F1"/>
+                    </a:solidFill>
+                  </a:tcPr>
+                </a:tc>
+                <a:tc>
+                  <a:txBody>
+                    <a:bodyPr/>
+                    <a:lstStyle/>
+                    <a:p>
+                      <a:r>
+                        <a:rPr sz="1100">
+                          <a:solidFill>
+                            <a:srgbClr val="2C3E50"/>
+                          </a:solidFill>
+                        </a:rPr>
+                        <a:t>11</a:t>
+                      </a:r>
+                    </a:p>
+                  </a:txBody>
+                  <a:tcPr>
+                    <a:solidFill>
+                      <a:srgbClr val="ECF0F1"/>
+                    </a:solidFill>
+                  </a:tcPr>
+                </a:tc>
+                <a:tc>
+                  <a:txBody>
+                    <a:bodyPr/>
+                    <a:lstStyle/>
+                    <a:p>
+                      <a:r>
+                        <a:rPr sz="1100">
+                          <a:solidFill>
+                            <a:srgbClr val="2C3E50"/>
+                          </a:solidFill>
+                        </a:rPr>
+                        <a:t>275</a:t>
+                      </a:r>
+                    </a:p>
+                  </a:txBody>
+                  <a:tcPr>
+                    <a:solidFill>
+                      <a:srgbClr val="ECF0F1"/>
+                    </a:solidFill>
+                  </a:tcPr>
+                </a:tc>
+              </a:tr>
+              <a:tr h="658368">
+                <a:tc>
+                  <a:txBody>
+                    <a:bodyPr/>
+                    <a:lstStyle/>
+                    <a:p>
+                      <a:r>
+                        <a:rPr sz="1100">
+                          <a:solidFill>
+                            <a:srgbClr val="2C3E50"/>
+                          </a:solidFill>
+                        </a:rPr>
+                        <a:t>Word2Vec</a:t>
+                      </a:r>
+                    </a:p>
+                  </a:txBody>
+                  <a:tcPr>
+                    <a:solidFill>
+                      <a:srgbClr val="FFFFFF"/>
+                    </a:solidFill>
+                  </a:tcPr>
+                </a:tc>
+                <a:tc>
+                  <a:txBody>
+                    <a:bodyPr/>
+                    <a:lstStyle/>
+                    <a:p>
+                      <a:r>
+                        <a:rPr sz="1100">
+                          <a:solidFill>
+                            <a:srgbClr val="2C3E50"/>
+                          </a:solidFill>
+                        </a:rPr>
+                        <a:t>0.7752</a:t>
+                      </a:r>
+                    </a:p>
+                  </a:txBody>
+                  <a:tcPr>
+                    <a:solidFill>
+                      <a:srgbClr val="FFFFFF"/>
+                    </a:solidFill>
+                  </a:tcPr>
+                </a:tc>
+                <a:tc>
+                  <a:txBody>
+                    <a:bodyPr/>
+                    <a:lstStyle/>
+                    <a:p>
+                      <a:r>
+                        <a:rPr sz="1100">
+                          <a:solidFill>
+                            <a:srgbClr val="2C3E50"/>
+                          </a:solidFill>
+                        </a:rPr>
+                        <a:t>0.0386</a:t>
+                      </a:r>
+                    </a:p>
+                  </a:txBody>
+                  <a:tcPr>
+                    <a:solidFill>
+                      <a:srgbClr val="FFFFFF"/>
+                    </a:solidFill>
+                  </a:tcPr>
+                </a:tc>
+                <a:tc>
+                  <a:txBody>
+                    <a:bodyPr/>
+                    <a:lstStyle/>
+                    <a:p>
+                      <a:r>
+                        <a:rPr sz="1100">
+                          <a:solidFill>
+                            <a:srgbClr val="2C3E50"/>
+                          </a:solidFill>
+                        </a:rPr>
+                        <a:t>10</a:t>
+                      </a:r>
+                    </a:p>
+                  </a:txBody>
+                  <a:tcPr>
+                    <a:solidFill>
+                      <a:srgbClr val="FFFFFF"/>
+                    </a:solidFill>
+                  </a:tcPr>
+                </a:tc>
+                <a:tc>
+                  <a:txBody>
+                    <a:bodyPr/>
+                    <a:lstStyle/>
+                    <a:p>
+                      <a:r>
+                        <a:rPr sz="1100">
+                          <a:solidFill>
+                            <a:srgbClr val="2C3E50"/>
+                          </a:solidFill>
+                        </a:rPr>
+                        <a:t>250</a:t>
+                      </a:r>
+                    </a:p>
+                  </a:txBody>
+                  <a:tcPr>
+                    <a:solidFill>
+                      <a:srgbClr val="FFFFFF"/>
+                    </a:solidFill>
+                  </a:tcPr>
+                </a:tc>
+              </a:tr>
+              <a:tr h="658368">
+                <a:tc>
+                  <a:txBody>
+                    <a:bodyPr/>
+                    <a:lstStyle/>
+                    <a:p>
+                      <a:r>
+                        <a:rPr sz="1100">
+                          <a:solidFill>
+                            <a:srgbClr val="2C3E50"/>
+                          </a:solidFill>
+                        </a:rPr>
+                        <a:t>Doc2Vec</a:t>
+                      </a:r>
+                    </a:p>
+                  </a:txBody>
+                  <a:tcPr>
+                    <a:solidFill>
+                      <a:srgbClr val="ECF0F1"/>
+                    </a:solidFill>
+                  </a:tcPr>
+                </a:tc>
+                <a:tc>
+                  <a:txBody>
+                    <a:bodyPr/>
+                    <a:lstStyle/>
+                    <a:p>
+                      <a:r>
+                        <a:rPr sz="1100">
+                          <a:solidFill>
+                            <a:srgbClr val="2C3E50"/>
+                          </a:solidFill>
+                        </a:rPr>
+                        <a:t>0.7508</a:t>
+                      </a:r>
+                    </a:p>
+                  </a:txBody>
+                  <a:tcPr>
+                    <a:solidFill>
+                      <a:srgbClr val="ECF0F1"/>
+                    </a:solidFill>
+                  </a:tcPr>
+                </a:tc>
+                <a:tc>
+                  <a:txBody>
+                    <a:bodyPr/>
+                    <a:lstStyle/>
+                    <a:p>
+                      <a:r>
+                        <a:rPr sz="1100">
+                          <a:solidFill>
+                            <a:srgbClr val="2C3E50"/>
+                          </a:solidFill>
+                        </a:rPr>
+                        <a:t>0.0394</a:t>
+                      </a:r>
+                    </a:p>
+                  </a:txBody>
+                  <a:tcPr>
+                    <a:solidFill>
+                      <a:srgbClr val="ECF0F1"/>
+                    </a:solidFill>
+                  </a:tcPr>
+                </a:tc>
+                <a:tc>
+                  <a:txBody>
+                    <a:bodyPr/>
+                    <a:lstStyle/>
+                    <a:p>
+                      <a:r>
+                        <a:rPr sz="1100">
+                          <a:solidFill>
+                            <a:srgbClr val="2C3E50"/>
+                          </a:solidFill>
+                        </a:rPr>
+                        <a:t>6</a:t>
+                      </a:r>
+                    </a:p>
+                  </a:txBody>
+                  <a:tcPr>
+                    <a:solidFill>
+                      <a:srgbClr val="ECF0F1"/>
+                    </a:solidFill>
+                  </a:tcPr>
+                </a:tc>
+                <a:tc>
+                  <a:txBody>
+                    <a:bodyPr/>
+                    <a:lstStyle/>
+                    <a:p>
+                      <a:r>
+                        <a:rPr sz="1100">
+                          <a:solidFill>
+                            <a:srgbClr val="2C3E50"/>
+                          </a:solidFill>
+                        </a:rPr>
+                        <a:t>150</a:t>
+                      </a:r>
+                    </a:p>
+                  </a:txBody>
+                  <a:tcPr>
+                    <a:solidFill>
+                      <a:srgbClr val="ECF0F1"/>
+                    </a:solidFill>
+                  </a:tcPr>
+                </a:tc>
+              </a:tr>
+            </a:tbl>
+          </a:graphicData>
+        </a:graphic>
+      </p:graphicFrame>
+      <p:sp>
+        <p:nvSpPr>
+          <p:cNvPr id="5" name="TextBox 4"/>
+          <p:cNvSpPr txBox="1"/>
+          <p:nvPr/>
+        </p:nvSpPr>
+        <p:spPr>
+          <a:xfrm>
+            <a:off x="1371600" y="5029200"/>
+            <a:ext cx="9418320" cy="914400"/>
+          </a:xfrm>
+          <a:prstGeom prst="rect">
+            <a:avLst/>
+          </a:prstGeom>
+          <a:noFill/>
+        </p:spPr>
+        <p:txBody>
+          <a:bodyPr wrap="square">
+            <a:spAutoFit/>
+          </a:bodyPr>
+          <a:lstStyle/>
+          <a:p>
+            <a:r>
+              <a:rPr sz="1100" i="1">
+                <a:solidFill>
+                  <a:srgbClr val="2C3E50"/>
+                </a:solidFill>
+              </a:rPr>
+              <a:t>Note: averages mix in different classifier choices. Pattern — CountVec leads because it carries our ExtraTrees winner; FastText/Word2Vec/Doc2Vec families are pulled down by their BRF/DL classifier pairings.</a:t>
+            </a:r>
+          </a:p>
+        </p:txBody>
+      </p:sp>
+      <p:sp>
+        <p:nvSpPr>
+          <p:cNvPr id="6" name="TextBox 5"/>
+          <p:cNvSpPr txBox="1"/>
+          <p:nvPr/>
+        </p:nvSpPr>
+        <p:spPr>
+          <a:xfrm>
+            <a:off x="457200" y="6492240"/>
+            <a:ext cx="11277295" cy="274320"/>
+          </a:xfrm>
+          <a:prstGeom prst="rect">
+            <a:avLst/>
+          </a:prstGeom>
+          <a:noFill/>
+        </p:spPr>
+        <p:txBody>
+          <a:bodyPr wrap="none">
+            <a:spAutoFit/>
+          </a:bodyPr>
+          <a:lstStyle/>
+          <a:p>
+            <a:pPr algn="l"/>
+            <a:r>
+              <a:rPr sz="900" i="1">
+                <a:solidFill>
+                  <a:srgbClr val="7F8C8D"/>
+                </a:solidFill>
+              </a:rPr>
+              <a:t>subFinder substrate prediction — rep_1 reference run</a:t>
+            </a:r>
+          </a:p>
+        </p:txBody>
+      </p:sp>
+    </p:spTree>
+  </p:cSld>
+  <p:clrMapOvr>
+    <a:masterClrMapping/>
+  </p:clrMapOvr>
+</p:sld>
+</file>
+
+<file path=ppt/slides/slide21.xml><?xml version="1.0" encoding="utf-8"?>
+<p:sld xmlns:a="http://schemas.openxmlformats.org/drawingml/2006/main" xmlns:p="http://schemas.openxmlformats.org/presentationml/2006/main" xmlns:r="http://schemas.openxmlformats.org/officeDocument/2006/relationships">
+  <p:cSld>
+    <p:spTree>
+      <p:nvGrpSpPr>
+        <p:cNvPr id="1" name=""/>
+        <p:cNvGrpSpPr/>
+        <p:nvPr/>
+      </p:nvGrpSpPr>
+      <p:grpSpPr/>
+      <p:sp>
+        <p:nvSpPr>
+          <p:cNvPr id="2" name="TextBox 1"/>
+          <p:cNvSpPr txBox="1"/>
+          <p:nvPr/>
+        </p:nvSpPr>
+        <p:spPr>
+          <a:xfrm>
+            <a:off x="548640" y="320040"/>
+            <a:ext cx="11094415" cy="822960"/>
+          </a:xfrm>
+          <a:prstGeom prst="rect">
+            <a:avLst/>
+          </a:prstGeom>
+          <a:noFill/>
+        </p:spPr>
+        <p:txBody>
+          <a:bodyPr wrap="square">
+            <a:spAutoFit/>
+          </a:bodyPr>
+          <a:lstStyle/>
+          <a:p>
+            <a:pPr algn="l"/>
+            <a:r>
+              <a:rPr sz="2800" b="1">
+                <a:solidFill>
+                  <a:srgbClr val="1A3A5C"/>
+                </a:solidFill>
+              </a:rPr>
               <a:t>Appendix · Performance by classifier family</a:t>
             </a:r>
           </a:p>
@@ -13781,7 +14574,7 @@
 </p:sld>
 </file>
 
-<file path=ppt/slides/slide19.xml><?xml version="1.0" encoding="utf-8"?>
+<file path=ppt/slides/slide22.xml><?xml version="1.0" encoding="utf-8"?>
 <p:sld xmlns:a="http://schemas.openxmlformats.org/drawingml/2006/main" xmlns:p="http://schemas.openxmlformats.org/presentationml/2006/main" xmlns:r="http://schemas.openxmlformats.org/officeDocument/2006/relationships">
   <p:cSld>
     <p:spTree>
@@ -13959,7 +14752,7 @@
 </p:sld>
 </file>
 
-<file path=ppt/slides/slide2.xml><?xml version="1.0" encoding="utf-8"?>
+<file path=ppt/slides/slide23.xml><?xml version="1.0" encoding="utf-8"?>
 <p:sld xmlns:a="http://schemas.openxmlformats.org/drawingml/2006/main" xmlns:p="http://schemas.openxmlformats.org/presentationml/2006/main" xmlns:r="http://schemas.openxmlformats.org/officeDocument/2006/relationships">
   <p:cSld>
     <p:spTree>
@@ -13998,241 +14791,6 @@
                   <a:srgbClr val="1A3A5C"/>
                 </a:solidFill>
               </a:rPr>
-              <a:t>Problem setup</a:t>
-            </a:r>
-          </a:p>
-        </p:txBody>
-      </p:sp>
-      <p:sp>
-        <p:nvSpPr>
-          <p:cNvPr id="3" name="TextBox 2"/>
-          <p:cNvSpPr txBox="1"/>
-          <p:nvPr/>
-        </p:nvSpPr>
-        <p:spPr>
-          <a:xfrm>
-            <a:off x="548640" y="960120"/>
-            <a:ext cx="11094415" cy="365760"/>
-          </a:xfrm>
-          <a:prstGeom prst="rect">
-            <a:avLst/>
-          </a:prstGeom>
-          <a:noFill/>
-        </p:spPr>
-        <p:txBody>
-          <a:bodyPr wrap="square">
-            <a:spAutoFit/>
-          </a:bodyPr>
-          <a:lstStyle/>
-          <a:p>
-            <a:pPr algn="l"/>
-            <a:r>
-              <a:rPr sz="1400">
-                <a:solidFill>
-                  <a:srgbClr val="7F8C8D"/>
-                </a:solidFill>
-              </a:rPr>
-              <a:t>Predict one of 12 polysaccharide substrate classes from a PUL's gene-token sequence</a:t>
-            </a:r>
-          </a:p>
-        </p:txBody>
-      </p:sp>
-      <p:sp>
-        <p:nvSpPr>
-          <p:cNvPr id="4" name="TextBox 3"/>
-          <p:cNvSpPr txBox="1"/>
-          <p:nvPr/>
-        </p:nvSpPr>
-        <p:spPr>
-          <a:xfrm>
-            <a:off x="548640" y="1645920"/>
-            <a:ext cx="10515600" cy="4572000"/>
-          </a:xfrm>
-          <a:prstGeom prst="rect">
-            <a:avLst/>
-          </a:prstGeom>
-          <a:noFill/>
-        </p:spPr>
-        <p:txBody>
-          <a:bodyPr wrap="square">
-            <a:spAutoFit/>
-          </a:bodyPr>
-          <a:lstStyle/>
-          <a:p>
-            <a:pPr algn="l">
-              <a:spcAft>
-                <a:spcPts val="1400"/>
-              </a:spcAft>
-            </a:pPr>
-            <a:r>
-              <a:rPr sz="1500" b="1">
-                <a:solidFill>
-                  <a:srgbClr val="1A3A5C"/>
-                </a:solidFill>
-              </a:rPr>
-              <a:t>Dataset — </a:t>
-            </a:r>
-            <a:r>
-              <a:rPr sz="1500">
-                <a:solidFill>
-                  <a:srgbClr val="2C3E50"/>
-                </a:solidFill>
-              </a:rPr>
-              <a:t>1,030 labeled PULs across 12 substrates (alginate, alpha-glucan, alpha-mannan, arabinogalactan, beta-glucan, beta-mannan, chitin, fructan, galactan, host glycan, pectin, xylan)</a:t>
-            </a:r>
-          </a:p>
-          <a:p>
-            <a:pPr algn="l">
-              <a:spcAft>
-                <a:spcPts val="1400"/>
-              </a:spcAft>
-            </a:pPr>
-            <a:r>
-              <a:rPr sz="1500" b="1">
-                <a:solidFill>
-                  <a:srgbClr val="1A3A5C"/>
-                </a:solidFill>
-              </a:rPr>
-              <a:t>Each PUL — </a:t>
-            </a:r>
-            <a:r>
-              <a:rPr sz="1500">
-                <a:solidFill>
-                  <a:srgbClr val="2C3E50"/>
-                </a:solidFill>
-              </a:rPr>
-              <a:t>a comma/pipe-separated string of CAZy family IDs, transporter classification IDs, transcription-factor types, and null padding</a:t>
-            </a:r>
-          </a:p>
-          <a:p>
-            <a:pPr algn="l">
-              <a:spcAft>
-                <a:spcPts val="1400"/>
-              </a:spcAft>
-            </a:pPr>
-            <a:r>
-              <a:rPr sz="1500" b="1">
-                <a:solidFill>
-                  <a:srgbClr val="1A3A5C"/>
-                </a:solidFill>
-              </a:rPr>
-              <a:t>Cross-validation — </a:t>
-            </a:r>
-            <a:r>
-              <a:rPr sz="1500">
-                <a:solidFill>
-                  <a:srgbClr val="2C3E50"/>
-                </a:solidFill>
-              </a:rPr>
-              <a:t>5-repeat × 5-fold Repeated Stratified K-Fold (n=25 trials per configuration) — leak-free: word-embedding models retrained per fold</a:t>
-            </a:r>
-          </a:p>
-          <a:p>
-            <a:pPr algn="l">
-              <a:spcAft>
-                <a:spcPts val="1400"/>
-              </a:spcAft>
-            </a:pPr>
-            <a:r>
-              <a:rPr sz="1500" b="1">
-                <a:solidFill>
-                  <a:srgbClr val="1A3A5C"/>
-                </a:solidFill>
-              </a:rPr>
-              <a:t>Goal — </a:t>
-            </a:r>
-            <a:r>
-              <a:rPr sz="1500">
-                <a:solidFill>
-                  <a:srgbClr val="2C3E50"/>
-                </a:solidFill>
-              </a:rPr>
-              <a:t>(1) maximise predictive accuracy, (2) emit calibrated probabilities, (3) produce per-PUL signature-gene attributions that match literature CAZy knowledge</a:t>
-            </a:r>
-          </a:p>
-        </p:txBody>
-      </p:sp>
-      <p:sp>
-        <p:nvSpPr>
-          <p:cNvPr id="5" name="TextBox 4"/>
-          <p:cNvSpPr txBox="1"/>
-          <p:nvPr/>
-        </p:nvSpPr>
-        <p:spPr>
-          <a:xfrm>
-            <a:off x="457200" y="6492240"/>
-            <a:ext cx="11277295" cy="274320"/>
-          </a:xfrm>
-          <a:prstGeom prst="rect">
-            <a:avLst/>
-          </a:prstGeom>
-          <a:noFill/>
-        </p:spPr>
-        <p:txBody>
-          <a:bodyPr wrap="none">
-            <a:spAutoFit/>
-          </a:bodyPr>
-          <a:lstStyle/>
-          <a:p>
-            <a:pPr algn="l"/>
-            <a:r>
-              <a:rPr sz="900" i="1">
-                <a:solidFill>
-                  <a:srgbClr val="7F8C8D"/>
-                </a:solidFill>
-              </a:rPr>
-              <a:t>subFinder substrate prediction — rep_1 reference run</a:t>
-            </a:r>
-          </a:p>
-        </p:txBody>
-      </p:sp>
-    </p:spTree>
-  </p:cSld>
-  <p:clrMapOvr>
-    <a:masterClrMapping/>
-  </p:clrMapOvr>
-</p:sld>
-</file>
-
-<file path=ppt/slides/slide20.xml><?xml version="1.0" encoding="utf-8"?>
-<p:sld xmlns:a="http://schemas.openxmlformats.org/drawingml/2006/main" xmlns:p="http://schemas.openxmlformats.org/presentationml/2006/main" xmlns:r="http://schemas.openxmlformats.org/officeDocument/2006/relationships">
-  <p:cSld>
-    <p:spTree>
-      <p:nvGrpSpPr>
-        <p:cNvPr id="1" name=""/>
-        <p:cNvGrpSpPr/>
-        <p:nvPr/>
-      </p:nvGrpSpPr>
-      <p:grpSpPr/>
-      <p:sp>
-        <p:nvSpPr>
-          <p:cNvPr id="2" name="TextBox 1"/>
-          <p:cNvSpPr txBox="1"/>
-          <p:nvPr/>
-        </p:nvSpPr>
-        <p:spPr>
-          <a:xfrm>
-            <a:off x="548640" y="320040"/>
-            <a:ext cx="11094415" cy="822960"/>
-          </a:xfrm>
-          <a:prstGeom prst="rect">
-            <a:avLst/>
-          </a:prstGeom>
-          <a:noFill/>
-        </p:spPr>
-        <p:txBody>
-          <a:bodyPr wrap="square">
-            <a:spAutoFit/>
-          </a:bodyPr>
-          <a:lstStyle/>
-          <a:p>
-            <a:pPr algn="l"/>
-            <a:r>
-              <a:rPr sz="2800" b="1">
-                <a:solidFill>
-                  <a:srgbClr val="1A3A5C"/>
-                </a:solidFill>
-              </a:rPr>
               <a:t>Appendix · Substrate-alias map between literature DB and our 12 classes</a:t>
             </a:r>
           </a:p>
@@ -15460,7 +16018,7 @@
 </p:sld>
 </file>
 
-<file path=ppt/slides/slide21.xml><?xml version="1.0" encoding="utf-8"?>
+<file path=ppt/slides/slide24.xml><?xml version="1.0" encoding="utf-8"?>
 <p:sld xmlns:a="http://schemas.openxmlformats.org/drawingml/2006/main" xmlns:p="http://schemas.openxmlformats.org/presentationml/2006/main" xmlns:r="http://schemas.openxmlformats.org/officeDocument/2006/relationships">
   <p:cSld>
     <p:spTree>

</xml_diff>